<commit_message>
Polish deck text + add rendered cover.png: cite live risk-gate block + decision journal on slides 4 & 6, cover exported to PNG (2400x1260)
</commit_message>
<xml_diff>
--- a/presentation.pptx
+++ b/presentation.pptx
@@ -3891,7 +3891,7 @@
         <p:spPr>
           <a:xfrm>
             <a:off x="822960" y="4846320"/>
-            <a:ext cx="10515600" cy="640080"/>
+            <a:ext cx="10515600" cy="822960"/>
           </a:xfrm>
           <a:prstGeom prst="rect">
             <a:avLst/>
@@ -3915,7 +3915,7 @@
                 <a:ea typeface="Calibri" pitchFamily="34" charset="-122"/>
                 <a:cs typeface="Calibri" pitchFamily="34" charset="-120"/>
               </a:rPr>
-              <a:t>The signal decides direction. The risk gates decide if — and how big. Orders execute through Alpaca's MCP server.</a:t>
+              <a:t>The signal decides direction; the risk gates decide if — and how big. Orders execute through Alpaca's MCP — autonomously each market-hours cycle, with every decision logged to a journal.</a:t>
             </a:r>
             <a:endParaRPr lang="en-US" sz="1600" dirty="0"/>
           </a:p>
@@ -5276,7 +5276,7 @@
                 <a:ea typeface="Calibri" pitchFamily="34" charset="-122"/>
                 <a:cs typeface="Calibri" pitchFamily="34" charset="-120"/>
               </a:rPr>
-              <a:t>In testing, the gates correctly REFUSED SPY &amp; QQQ trades that exceeded the 2% cap — protection working.</a:t>
+              <a:t>Real evidence: at the 5-position cap the agent REFUSED further signals — and every block is logged in the decision journal.</a:t>
             </a:r>
             <a:endParaRPr lang="en-US" sz="1400" dirty="0"/>
           </a:p>

</xml_diff>

<commit_message>
Fill in final results (+1.82%, 2 take-profits +54%/+74%, 0 stops, 87 gate blocks) across slide 9, WRITEUP, LinkedIn post 3
</commit_message>
<xml_diff>
--- a/presentation.pptx
+++ b/presentation.pptx
@@ -6406,7 +6406,7 @@
                 <a:ea typeface="Calibri" pitchFamily="34" charset="-122"/>
                 <a:cs typeface="Calibri" pitchFamily="34" charset="-120"/>
               </a:rPr>
-              <a:t>[  __%  ]</a:t>
+              <a:t>+1.82%</a:t>
             </a:r>
             <a:endParaRPr lang="en-US" sz="2800" dirty="0"/>
           </a:p>
@@ -6511,7 +6511,7 @@
                 <a:ea typeface="Calibri" pitchFamily="34" charset="-122"/>
                 <a:cs typeface="Calibri" pitchFamily="34" charset="-120"/>
               </a:rPr>
-              <a:t>[  __  ]</a:t>
+              <a:t>9</a:t>
             </a:r>
             <a:endParaRPr lang="en-US" sz="2800" dirty="0"/>
           </a:p>
@@ -6616,7 +6616,7 @@
                 <a:ea typeface="Calibri" pitchFamily="34" charset="-122"/>
                 <a:cs typeface="Calibri" pitchFamily="34" charset="-120"/>
               </a:rPr>
-              <a:t>[ _ / _ ]</a:t>
+              <a:t>2 / 0</a:t>
             </a:r>
             <a:endParaRPr lang="en-US" sz="2800" dirty="0"/>
           </a:p>
@@ -6721,7 +6721,7 @@
                 <a:ea typeface="Calibri" pitchFamily="34" charset="-122"/>
                 <a:cs typeface="Calibri" pitchFamily="34" charset="-120"/>
               </a:rPr>
-              <a:t>[  __  ]</a:t>
+              <a:t>87</a:t>
             </a:r>
             <a:endParaRPr lang="en-US" sz="2800" dirty="0"/>
           </a:p>
@@ -6826,7 +6826,24 @@
                 <a:ea typeface="Calibri" pitchFamily="34" charset="-122"/>
                 <a:cs typeface="Calibri" pitchFamily="34" charset="-120"/>
               </a:rPr>
-              <a:t>[ Screenshot: Alpaca paper P&amp;L + the live status dashboard ]</a:t>
+              <a:t>Final equity $101,823  ·  +1.82% on the week  ·  2 take-profits captured (+54%, +74%)  ·  0 stop-losses</a:t>
+            </a:r>
+            <a:endParaRPr lang="en-US" sz="1600" dirty="0"/>
+          </a:p>
+          <a:p>
+            <a:pPr algn="ctr" indent="0" marL="0">
+              <a:buNone/>
+            </a:pPr>
+            <a:r>
+              <a:rPr lang="en-US" sz="1600" i="1" dirty="0">
+                <a:solidFill>
+                  <a:srgbClr val="8FA0B5"/>
+                </a:solidFill>
+                <a:latin typeface="Calibri" pitchFamily="34" charset="0"/>
+                <a:ea typeface="Calibri" pitchFamily="34" charset="-122"/>
+                <a:cs typeface="Calibri" pitchFamily="34" charset="-120"/>
+              </a:rPr>
+              <a:t>[ add screenshot: Alpaca equity curve + P&amp;L ]</a:t>
             </a:r>
             <a:endParaRPr lang="en-US" sz="1600" dirty="0"/>
           </a:p>

</xml_diff>